<commit_message>
update model and notebook
update the new model ,notebook and app
</commit_message>
<xml_diff>
--- a/presentation/World_Cup_Presentation.pptx
+++ b/presentation/World_Cup_Presentation.pptx
@@ -8645,6 +8645,10 @@
           </a:solidFill>
           <a:ln/>
         </p:spPr>
+        <p:txBody>
+          <a:bodyPr/>
+          <a:p/>
+        </p:txBody>
       </p:sp>
       <p:sp>
         <p:nvSpPr>
@@ -8707,6 +8711,10 @@
           </a:solidFill>
           <a:ln/>
         </p:spPr>
+        <p:txBody>
+          <a:bodyPr/>
+          <a:p/>
+        </p:txBody>
       </p:sp>
       <p:sp>
         <p:nvSpPr>
@@ -8769,6 +8777,10 @@
           </a:solidFill>
           <a:ln/>
         </p:spPr>
+        <p:txBody>
+          <a:bodyPr/>
+          <a:p/>
+        </p:txBody>
       </p:sp>
       <p:sp>
         <p:nvSpPr>
@@ -8870,6 +8882,10 @@
           </a:solidFill>
           <a:ln/>
         </p:spPr>
+        <p:txBody>
+          <a:bodyPr/>
+          <a:p/>
+        </p:txBody>
       </p:sp>
       <p:sp>
         <p:nvSpPr>
@@ -8907,7 +8923,7 @@
                 <a:ea typeface="Calibri" pitchFamily="34" charset="-122"/>
                 <a:cs typeface="Calibri" pitchFamily="34" charset="-120"/>
               </a:rPr>
-              <a:t>Player-level features (FIFA ratings, market values) and tournament-importance weighting</a:t>
+              <a:t>Player-level features (FIFA ratings, market values, injury/suspension news) - the clearest remaining gap, since match importance and rest days are already tested and added</a:t>
             </a:r>
             <a:endParaRPr lang="en-US" sz="1250" dirty="0"/>
           </a:p>
@@ -8932,6 +8948,10 @@
           </a:solidFill>
           <a:ln/>
         </p:spPr>
+        <p:txBody>
+          <a:bodyPr/>
+          <a:p/>
+        </p:txBody>
       </p:sp>
       <p:sp>
         <p:nvSpPr>
@@ -8994,6 +9014,10 @@
           </a:solidFill>
           <a:ln/>
         </p:spPr>
+        <p:txBody>
+          <a:bodyPr/>
+          <a:p/>
+        </p:txBody>
       </p:sp>
       <p:sp>
         <p:nvSpPr>
@@ -9056,6 +9080,10 @@
           </a:solidFill>
           <a:ln/>
         </p:spPr>
+        <p:txBody>
+          <a:bodyPr/>
+          <a:p/>
+        </p:txBody>
       </p:sp>
       <p:sp>
         <p:nvSpPr>

</xml_diff>

<commit_message>
update one more data resource
</commit_message>
<xml_diff>
--- a/presentation/World_Cup_Presentation.pptx
+++ b/presentation/World_Cup_Presentation.pptx
@@ -10071,6 +10071,10 @@
           </a:solidFill>
           <a:ln/>
         </p:spPr>
+        <p:txBody>
+          <a:bodyPr/>
+          <a:p/>
+        </p:txBody>
       </p:sp>
       <p:sp>
         <p:nvSpPr>
@@ -10172,6 +10176,10 @@
             <a:prstDash val="solid"/>
           </a:ln>
         </p:spPr>
+        <p:txBody>
+          <a:bodyPr/>
+          <a:p/>
+        </p:txBody>
       </p:sp>
       <p:sp>
         <p:nvSpPr>
@@ -10229,7 +10237,7 @@
                 <a:ea typeface="Calibri" pitchFamily="34" charset="-122"/>
                 <a:cs typeface="Calibri" pitchFamily="34" charset="-120"/>
               </a:rPr>
-              <a:t>Kaggle — International Football Results (martj42)</a:t>
+              <a:t>Kaggle — International Football Results (martj42) + FIFA World Cup All Dataset (abhijitdahatonde)</a:t>
             </a:r>
             <a:endParaRPr lang="en-US" sz="1200" dirty="0"/>
           </a:p>
@@ -11254,7 +11262,7 @@
                 <a:ea typeface="Calibri" pitchFamily="34" charset="-122"/>
                 <a:cs typeface="Calibri" pitchFamily="34" charset="-120"/>
               </a:rPr>
-              <a:t>International Football Results, 1872–2026 — Kaggle (martj42), continuously-updated snapshot</a:t>
+              <a:t>International Football Results, 1872–2026 — Kaggle (martj42) + FIFA World Cup All Dataset (abhijitdahatonde)</a:t>
             </a:r>
             <a:endParaRPr lang="en-US" sz="1400" dirty="0"/>
           </a:p>
@@ -11281,6 +11289,10 @@
           </a:solidFill>
           <a:ln/>
         </p:spPr>
+        <p:txBody>
+          <a:bodyPr/>
+          <a:p/>
+        </p:txBody>
       </p:sp>
       <p:sp>
         <p:nvSpPr>
@@ -11381,6 +11393,10 @@
           </a:solidFill>
           <a:ln/>
         </p:spPr>
+        <p:txBody>
+          <a:bodyPr/>
+          <a:p/>
+        </p:txBody>
       </p:sp>
       <p:sp>
         <p:nvSpPr>
@@ -11481,6 +11497,10 @@
           </a:solidFill>
           <a:ln/>
         </p:spPr>
+        <p:txBody>
+          <a:bodyPr/>
+          <a:p/>
+        </p:txBody>
       </p:sp>
       <p:sp>
         <p:nvSpPr>
@@ -11581,6 +11601,10 @@
           </a:solidFill>
           <a:ln/>
         </p:spPr>
+        <p:txBody>
+          <a:bodyPr/>
+          <a:p/>
+        </p:txBody>
       </p:sp>
       <p:sp>
         <p:nvSpPr>
@@ -11615,7 +11639,7 @@
                 <a:ea typeface="Cambria" pitchFamily="34" charset="-122"/>
                 <a:cs typeface="Cambria" pitchFamily="34" charset="-120"/>
               </a:rPr>
-              <a:t>3</a:t>
+              <a:t>4</a:t>
             </a:r>
             <a:endParaRPr lang="en-US" sz="3200" dirty="0"/>
           </a:p>
@@ -11759,6 +11783,10 @@
           </a:solidFill>
           <a:ln/>
         </p:spPr>
+        <p:txBody>
+          <a:bodyPr/>
+          <a:p/>
+        </p:txBody>
       </p:sp>
       <p:sp>
         <p:nvSpPr>
@@ -11781,6 +11809,10 @@
           </a:solidFill>
           <a:ln/>
         </p:spPr>
+        <p:txBody>
+          <a:bodyPr/>
+          <a:p/>
+        </p:txBody>
       </p:sp>
       <p:sp>
         <p:nvSpPr>
@@ -11881,6 +11913,10 @@
           </a:solidFill>
           <a:ln/>
         </p:spPr>
+        <p:txBody>
+          <a:bodyPr/>
+          <a:p/>
+        </p:txBody>
       </p:sp>
       <p:sp>
         <p:nvSpPr>
@@ -11903,6 +11939,10 @@
           </a:solidFill>
           <a:ln/>
         </p:spPr>
+        <p:txBody>
+          <a:bodyPr/>
+          <a:p/>
+        </p:txBody>
       </p:sp>
       <p:sp>
         <p:nvSpPr>
@@ -12003,6 +12043,10 @@
           </a:solidFill>
           <a:ln/>
         </p:spPr>
+        <p:txBody>
+          <a:bodyPr/>
+          <a:p/>
+        </p:txBody>
       </p:sp>
       <p:sp>
         <p:nvSpPr>
@@ -12025,6 +12069,10 @@
           </a:solidFill>
           <a:ln/>
         </p:spPr>
+        <p:txBody>
+          <a:bodyPr/>
+          <a:p/>
+        </p:txBody>
       </p:sp>
       <p:sp>
         <p:nvSpPr>

</xml_diff>